<commit_message>
fix: 总部 Irvine→LA / 删 CEO 信息 / 标准化公司名 (v0.4)
</commit_message>
<xml_diff>
--- a/decks/hengsheng-china-partner-2026-09-14/hengsheng-china-partner-v0.1.pptx
+++ b/decks/hengsheng-china-partner-2026-09-14/hengsheng-china-partner-v0.1.pptx
@@ -3570,7 +3570,7 @@
                 <a:ea typeface="Calibri" pitchFamily="34" charset="-122"/>
                 <a:cs typeface="Calibri" pitchFamily="34" charset="-120"/>
               </a:rPr>
-              <a:t>2026  ·  Irvine, CA</a:t>
+              <a:t>2026  ·  Los Angeles, CA</a:t>
             </a:r>
             <a:endParaRPr lang="en-US" sz="1000" dirty="0"/>
           </a:p>
@@ -23347,7 +23347,7 @@
                 <a:ea typeface="Microsoft YaHei" pitchFamily="34" charset="-122"/>
                 <a:cs typeface="Microsoft YaHei" pitchFamily="34" charset="-120"/>
               </a:rPr>
-              <a:t>总部：Irvine, CA, USA</a:t>
+              <a:t>总部：Los Angeles, CA, USA</a:t>
             </a:r>
             <a:endParaRPr lang="en-US" sz="1400" dirty="0"/>
           </a:p>
@@ -23416,17 +23416,6 @@
             <a:pPr indent="0" marL="0">
               <a:buNone/>
             </a:pPr>
-            <a:r>
-              <a:rPr lang="en-US" sz="1400" dirty="0">
-                <a:solidFill>
-                  <a:srgbClr val="FFFFFF"/>
-                </a:solidFill>
-                <a:latin typeface="Microsoft YaHei" pitchFamily="34" charset="0"/>
-                <a:ea typeface="Microsoft YaHei" pitchFamily="34" charset="-122"/>
-                <a:cs typeface="Microsoft YaHei" pitchFamily="34" charset="-120"/>
-              </a:rPr>
-              <a:t>CEO: Kevin Fan (范恒生)</a:t>
-            </a:r>
             <a:endParaRPr lang="en-US" sz="1400" dirty="0"/>
           </a:p>
         </p:txBody>
@@ -23455,17 +23444,6 @@
             <a:pPr indent="0" marL="0">
               <a:buNone/>
             </a:pPr>
-            <a:r>
-              <a:rPr lang="en-US" sz="1400" dirty="0">
-                <a:solidFill>
-                  <a:srgbClr val="94A3B8"/>
-                </a:solidFill>
-                <a:latin typeface="Calibri" pitchFamily="34" charset="0"/>
-                <a:ea typeface="Calibri" pitchFamily="34" charset="-122"/>
-                <a:cs typeface="Calibri" pitchFamily="34" charset="-120"/>
-              </a:rPr>
-              <a:t>pfa.kevinfan@gmail.com</a:t>
-            </a:r>
             <a:endParaRPr lang="en-US" sz="1400" dirty="0"/>
           </a:p>
         </p:txBody>
@@ -23780,7 +23758,7 @@
                 <a:ea typeface="Microsoft YaHei" pitchFamily="34" charset="-122"/>
                 <a:cs typeface="Microsoft YaHei" pitchFamily="34" charset="-120"/>
               </a:rPr>
-              <a:t>加州尔湾（Irvine, CA）</a:t>
+              <a:t>加州尔湾（Los Angeles, CA）</a:t>
             </a:r>
             <a:endParaRPr lang="en-US" sz="1400" dirty="0"/>
           </a:p>

</xml_diff>